<commit_message>
Audit scientific figures and fix boundary masks and misleading plot scales
</commit_message>
<xml_diff>
--- a/presentation/POLARIS-X_Numbered_Figures.pptx
+++ b/presentation/POLARIS-X_Numbered_Figures.pptx
@@ -786,7 +786,7 @@
           <a:lstStyle/>
           <a:p>
             <a:r>
-              <a:t>Reconstruction is conditional on known principal-axis orientation, thickness and optical coefficient. It estimates stress difference, not the full stress tensor. Low sensitivity, ambiguity and bounds can leave pixels unresolved. The local Gaussian uncertainty intervals exclude calibration and model uncertainty. This is a synthetic demonstration, not experimental validation.</a:t>
+              <a:t>Reconstruction is conditional on known principal-axis orientation, thickness and optical coefficient. This separate 1400 N case is not the same load as Figures 1–3. It estimates stress difference, not the full tensor. 1395 of 4072 material pixels are accepted. Median absolute error is 0.294 MPa, RMSE 1.421 MPa, and six accepted pixels exceed 5 MPa error; the largest error is 19.309 MPa due to an incorrect fringe branch. The shared map color scale now includes these outliers. Local approximate 95% interval coverage is 95.84% in this one synthetic realization; this does not establish experimental calibration. Full details: docs/FIGURE_AUDIT.md.</a:t>
             </a:r>
           </a:p>
         </p:txBody>
@@ -5017,7 +5017,7 @@
               </a:defRPr>
             </a:pPr>
             <a:r>
-              <a:t>• Same stress field viewed at analyzer angles of 0°, 45°, 90° and 135°.</a:t>
+              <a:t>• Same Kirsch field at nominal 1000 N, viewed at analyzer angles of 0°, 45°, 90° and 135°.</a:t>
             </a:r>
           </a:p>
         </p:txBody>
@@ -5405,7 +5405,7 @@
               </a:defRPr>
             </a:pPr>
             <a:r>
-              <a:t>• Triangular elements are refined near the hole, where stress changes rapidly.</a:t>
+              <a:t>• Finite plate at 1000 N: triangular elements are refined near the hole.</a:t>
             </a:r>
           </a:p>
         </p:txBody>
@@ -5793,7 +5793,7 @@
               </a:defRPr>
             </a:pPr>
             <a:r>
-              <a:t>• Principal stress difference is elevated near the upper and lower hole boundary.</a:t>
+              <a:t>• Finite plate at 1000 N: principal stress difference is elevated near the hole boundary.</a:t>
             </a:r>
           </a:p>
         </p:txBody>
@@ -5963,7 +5963,7 @@
               </a:defRPr>
             </a:pPr>
             <a:r>
-              <a:t>Image 4 — Stress reconstruction and uncertainty</a:t>
+              <a:t>Image 4 — Constrained reconstruction at 1400 N</a:t>
             </a:r>
           </a:p>
         </p:txBody>
@@ -6099,8 +6099,8 @@
         </p:blipFill>
         <p:spPr>
           <a:xfrm>
-            <a:off x="586739" y="1938726"/>
-            <a:ext cx="11018520" cy="2395330"/>
+            <a:off x="586739" y="1699851"/>
+            <a:ext cx="11018520" cy="2873081"/>
           </a:xfrm>
           <a:prstGeom prst="rect">
             <a:avLst/>
@@ -6181,7 +6181,7 @@
               </a:defRPr>
             </a:pPr>
             <a:r>
-              <a:t>• Compare reference stress difference with recovered values at valid pixels.</a:t>
+              <a:t>• Known orientation is supplied; 34.3% of material pixels pass the acceptance checks.</a:t>
             </a:r>
           </a:p>
         </p:txBody>
@@ -6217,7 +6217,7 @@
               </a:defRPr>
             </a:pPr>
             <a:r>
-              <a:t>• Blank reconstruction regions are unresolved or outside material; they do not mean zero stress.</a:t>
+              <a:t>• RMSE: 1.42 MPa; maximum error: 19.31 MPa. Acceptance does not guarantee correctness.</a:t>
             </a:r>
           </a:p>
         </p:txBody>
@@ -6253,7 +6253,7 @@
               </a:defRPr>
             </a:pPr>
             <a:r>
-              <a:t>• The approximate 95% interval half-width quantifies local uncertainty in MPa.</a:t>
+              <a:t>• Blank regions are unresolved or outside material. Local intervals exclude model/calibration error.</a:t>
             </a:r>
           </a:p>
         </p:txBody>

</xml_diff>